<commit_message>
Add show artwork to the proposal deck and export PDF
- Cover: vertical poster full-bleed on the right half
- CTA slide: wide banner as background under a dark tint
- Contact slide: show logo mark replaces the typographic title
- Ship a PDF export alongside the .pptx

Co-Authored-By: Claude Opus 5 <noreply@anthropic.com>
Claude-Session: https://claude.ai/code/session_01VVcYFC7m6jyhEcLisEEnrF
</commit_message>
<xml_diff>
--- a/prezentatsiya/Shunaqasi_ham_bop_turadi_Kommersiya_taklifi.pptx
+++ b/prezentatsiya/Shunaqasi_ham_bop_turadi_Kommersiya_taklifi.pptx
@@ -2415,65 +2415,38 @@
           <a:chExt cx="0" cy="0"/>
         </a:xfrm>
       </p:grpSpPr>
-      <p:sp>
-        <p:nvSpPr>
-          <p:cNvPr id="2" name="Shape 0"/>
-          <p:cNvSpPr/>
-          <p:nvPr/>
-        </p:nvSpPr>
-        <p:spPr>
-          <a:xfrm>
-            <a:off x="6675120" y="-1371600"/>
-            <a:ext cx="6949440" cy="6949440"/>
-          </a:xfrm>
-          <a:prstGeom prst="ellipse">
-            <a:avLst/>
-          </a:prstGeom>
-          <a:solidFill>
-            <a:srgbClr val="0D0D14"/>
-          </a:solidFill>
-          <a:ln w="12700">
-            <a:solidFill>
-              <a:srgbClr val="1E1E2A"/>
-            </a:solidFill>
-            <a:prstDash val="solid"/>
-          </a:ln>
-        </p:spPr>
-      </p:sp>
-      <p:sp>
-        <p:nvSpPr>
-          <p:cNvPr id="3" name="Shape 1"/>
-          <p:cNvSpPr/>
-          <p:nvPr/>
-        </p:nvSpPr>
-        <p:spPr>
-          <a:xfrm>
-            <a:off x="7863840" y="1737360"/>
-            <a:ext cx="5852160" cy="5852160"/>
-          </a:xfrm>
-          <a:prstGeom prst="ellipse">
-            <a:avLst/>
-          </a:prstGeom>
-          <a:solidFill>
-            <a:srgbClr val="0D0D14"/>
-          </a:solidFill>
-          <a:ln w="12700">
-            <a:solidFill>
-              <a:srgbClr val="1E1E2A"/>
-            </a:solidFill>
-            <a:prstDash val="solid"/>
-          </a:ln>
-        </p:spPr>
-      </p:sp>
-      <p:sp>
-        <p:nvSpPr>
-          <p:cNvPr id="4" name="Text 2"/>
-          <p:cNvSpPr/>
-          <p:nvPr/>
-        </p:nvSpPr>
-        <p:spPr>
-          <a:xfrm>
-            <a:off x="640080" y="1051560"/>
+      <p:pic>
+        <p:nvPicPr>
+          <p:cNvPr id="2" name="Image 0" descr="assets/poster.jpg">    </p:cNvPr>
+          <p:cNvPicPr>
+            <a:picLocks noChangeAspect="1"/>
+          </p:cNvPicPr>
+          <p:nvPr/>
+        </p:nvPicPr>
+        <p:blipFill>
+          <a:blip r:embed="rId1"/>
+          <a:srcRect l="0" r="0" t="0" b="0"/>
+          <a:stretch/>
+        </p:blipFill>
+        <p:spPr>
+          <a:xfrm>
+            <a:off x="7269480" y="0"/>
+            <a:ext cx="4922215" cy="6858000"/>
+          </a:xfrm>
+          <a:prstGeom prst="rect">
+            <a:avLst/>
+          </a:prstGeom>
+        </p:spPr>
+      </p:pic>
+      <p:sp>
+        <p:nvSpPr>
+          <p:cNvPr id="3" name="Text 0"/>
+          <p:cNvSpPr/>
+          <p:nvPr/>
+        </p:nvSpPr>
+        <p:spPr>
+          <a:xfrm>
+            <a:off x="640080" y="960120"/>
             <a:ext cx="6035040" cy="274320"/>
           </a:xfrm>
           <a:prstGeom prst="rect">
@@ -2506,23 +2479,23 @@
       </p:sp>
       <p:sp>
         <p:nvSpPr>
-          <p:cNvPr id="5" name="Text 3"/>
-          <p:cNvSpPr/>
-          <p:nvPr/>
-        </p:nvSpPr>
-        <p:spPr>
-          <a:xfrm>
-            <a:off x="640080" y="1481328"/>
-            <a:ext cx="6217920" cy="1920240"/>
-          </a:xfrm>
-          <a:prstGeom prst="rect">
-            <a:avLst/>
-          </a:prstGeom>
-          <a:noFill/>
-          <a:ln/>
-        </p:spPr>
-        <p:txBody>
-          <a:bodyPr wrap="square" lIns="0" tIns="0" rIns="0" bIns="0" rtlCol="0" anchor="ctr"/>
+          <p:cNvPr id="4" name="Text 1"/>
+          <p:cNvSpPr/>
+          <p:nvPr/>
+        </p:nvSpPr>
+        <p:spPr>
+          <a:xfrm>
+            <a:off x="640080" y="1389888"/>
+            <a:ext cx="6309360" cy="1920240"/>
+          </a:xfrm>
+          <a:prstGeom prst="rect">
+            <a:avLst/>
+          </a:prstGeom>
+          <a:noFill/>
+          <a:ln/>
+        </p:spPr>
+        <p:txBody>
+          <a:bodyPr wrap="square" lIns="0" tIns="0" rIns="0" bIns="0" rtlCol="0" anchor="t"/>
           <a:lstStyle/>
           <a:p>
             <a:pPr indent="0" marL="0">
@@ -2532,7 +2505,7 @@
               <a:buNone/>
             </a:pPr>
             <a:r>
-              <a:rPr lang="en-US" sz="4600" b="1" dirty="0">
+              <a:rPr lang="en-US" sz="4400" b="1" dirty="0">
                 <a:solidFill>
                   <a:srgbClr val="FFFFFF"/>
                 </a:solidFill>
@@ -2542,7 +2515,7 @@
               </a:rPr>
               <a:t>SHUNAQASI HAM</a:t>
             </a:r>
-            <a:endParaRPr lang="en-US" sz="4600" dirty="0"/>
+            <a:endParaRPr lang="en-US" sz="4400" dirty="0"/>
           </a:p>
           <a:p>
             <a:pPr indent="0" marL="0">
@@ -2552,7 +2525,7 @@
               <a:buNone/>
             </a:pPr>
             <a:r>
-              <a:rPr lang="en-US" sz="4600" b="1" dirty="0">
+              <a:rPr lang="en-US" sz="4400" b="1" dirty="0">
                 <a:solidFill>
                   <a:srgbClr val="FFFFFF"/>
                 </a:solidFill>
@@ -2562,20 +2535,20 @@
               </a:rPr>
               <a:t>BO‘P TURADI</a:t>
             </a:r>
-            <a:endParaRPr lang="en-US" sz="4600" dirty="0"/>
-          </a:p>
-        </p:txBody>
-      </p:sp>
-      <p:sp>
-        <p:nvSpPr>
-          <p:cNvPr id="6" name="Text 4"/>
-          <p:cNvSpPr/>
-          <p:nvPr/>
-        </p:nvSpPr>
-        <p:spPr>
-          <a:xfrm>
-            <a:off x="640080" y="3547872"/>
-            <a:ext cx="5989320" cy="868680"/>
+            <a:endParaRPr lang="en-US" sz="4400" dirty="0"/>
+          </a:p>
+        </p:txBody>
+      </p:sp>
+      <p:sp>
+        <p:nvSpPr>
+          <p:cNvPr id="5" name="Text 2"/>
+          <p:cNvSpPr/>
+          <p:nvPr/>
+        </p:nvSpPr>
+        <p:spPr>
+          <a:xfrm>
+            <a:off x="640080" y="3200400"/>
+            <a:ext cx="5943600" cy="822960"/>
           </a:xfrm>
           <a:prstGeom prst="rect">
             <a:avLst/>
@@ -2610,14 +2583,257 @@
       </p:sp>
       <p:sp>
         <p:nvSpPr>
-          <p:cNvPr id="7" name="Shape 5"/>
+          <p:cNvPr id="6" name="Text 3"/>
+          <p:cNvSpPr/>
+          <p:nvPr/>
+        </p:nvSpPr>
+        <p:spPr>
+          <a:xfrm>
+            <a:off x="640080" y="4206240"/>
+            <a:ext cx="1965960" cy="411480"/>
+          </a:xfrm>
+          <a:prstGeom prst="rect">
+            <a:avLst/>
+          </a:prstGeom>
+          <a:noFill/>
+          <a:ln/>
+        </p:spPr>
+        <p:txBody>
+          <a:bodyPr wrap="square" lIns="0" tIns="0" rIns="0" bIns="0" rtlCol="0" anchor="ctr"/>
+          <a:lstStyle/>
+          <a:p>
+            <a:pPr indent="0" marL="0">
+              <a:buNone/>
+            </a:pPr>
+            <a:r>
+              <a:rPr lang="en-US" sz="2200" b="1" dirty="0">
+                <a:solidFill>
+                  <a:srgbClr val="FFFFFF"/>
+                </a:solidFill>
+                <a:latin typeface="Arial" pitchFamily="34" charset="0"/>
+                <a:ea typeface="Arial" pitchFamily="34" charset="-122"/>
+                <a:cs typeface="Arial" pitchFamily="34" charset="-120"/>
+              </a:rPr>
+              <a:t>62 400+</a:t>
+            </a:r>
+            <a:endParaRPr lang="en-US" sz="2200" dirty="0"/>
+          </a:p>
+        </p:txBody>
+      </p:sp>
+      <p:sp>
+        <p:nvSpPr>
+          <p:cNvPr id="7" name="Text 4"/>
           <p:cNvSpPr/>
           <p:nvPr/>
         </p:nvSpPr>
         <p:spPr>
           <a:xfrm>
             <a:off x="640080" y="4617720"/>
-            <a:ext cx="4160520" cy="868680"/>
+            <a:ext cx="1965960" cy="457200"/>
+          </a:xfrm>
+          <a:prstGeom prst="rect">
+            <a:avLst/>
+          </a:prstGeom>
+          <a:noFill/>
+          <a:ln/>
+        </p:spPr>
+        <p:txBody>
+          <a:bodyPr wrap="square" lIns="0" tIns="0" rIns="0" bIns="0" rtlCol="0" anchor="ctr"/>
+          <a:lstStyle/>
+          <a:p>
+            <a:pPr indent="0" marL="0">
+              <a:lnSpc>
+                <a:spcPts val="1500"/>
+              </a:lnSpc>
+              <a:buNone/>
+            </a:pPr>
+            <a:r>
+              <a:rPr lang="en-US" sz="1150" dirty="0">
+                <a:solidFill>
+                  <a:srgbClr val="A2A2B5"/>
+                </a:solidFill>
+                <a:latin typeface="Calibri" pitchFamily="34" charset="0"/>
+                <a:ea typeface="Calibri" pitchFamily="34" charset="-122"/>
+                <a:cs typeface="Calibri" pitchFamily="34" charset="-120"/>
+              </a:rPr>
+              <a:t>YouTube obunachi</a:t>
+            </a:r>
+            <a:endParaRPr lang="en-US" sz="1150" dirty="0"/>
+          </a:p>
+        </p:txBody>
+      </p:sp>
+      <p:sp>
+        <p:nvSpPr>
+          <p:cNvPr id="8" name="Text 5"/>
+          <p:cNvSpPr/>
+          <p:nvPr/>
+        </p:nvSpPr>
+        <p:spPr>
+          <a:xfrm>
+            <a:off x="2743200" y="4206240"/>
+            <a:ext cx="1965960" cy="411480"/>
+          </a:xfrm>
+          <a:prstGeom prst="rect">
+            <a:avLst/>
+          </a:prstGeom>
+          <a:noFill/>
+          <a:ln/>
+        </p:spPr>
+        <p:txBody>
+          <a:bodyPr wrap="square" lIns="0" tIns="0" rIns="0" bIns="0" rtlCol="0" anchor="ctr"/>
+          <a:lstStyle/>
+          <a:p>
+            <a:pPr indent="0" marL="0">
+              <a:buNone/>
+            </a:pPr>
+            <a:r>
+              <a:rPr lang="en-US" sz="2200" b="1" dirty="0">
+                <a:solidFill>
+                  <a:srgbClr val="FFFFFF"/>
+                </a:solidFill>
+                <a:latin typeface="Arial" pitchFamily="34" charset="0"/>
+                <a:ea typeface="Arial" pitchFamily="34" charset="-122"/>
+                <a:cs typeface="Arial" pitchFamily="34" charset="-120"/>
+              </a:rPr>
+              <a:t>48</a:t>
+            </a:r>
+            <a:endParaRPr lang="en-US" sz="2200" dirty="0"/>
+          </a:p>
+        </p:txBody>
+      </p:sp>
+      <p:sp>
+        <p:nvSpPr>
+          <p:cNvPr id="9" name="Text 6"/>
+          <p:cNvSpPr/>
+          <p:nvPr/>
+        </p:nvSpPr>
+        <p:spPr>
+          <a:xfrm>
+            <a:off x="2743200" y="4617720"/>
+            <a:ext cx="1965960" cy="457200"/>
+          </a:xfrm>
+          <a:prstGeom prst="rect">
+            <a:avLst/>
+          </a:prstGeom>
+          <a:noFill/>
+          <a:ln/>
+        </p:spPr>
+        <p:txBody>
+          <a:bodyPr wrap="square" lIns="0" tIns="0" rIns="0" bIns="0" rtlCol="0" anchor="ctr"/>
+          <a:lstStyle/>
+          <a:p>
+            <a:pPr indent="0" marL="0">
+              <a:lnSpc>
+                <a:spcPts val="1500"/>
+              </a:lnSpc>
+              <a:buNone/>
+            </a:pPr>
+            <a:r>
+              <a:rPr lang="en-US" sz="1150" dirty="0">
+                <a:solidFill>
+                  <a:srgbClr val="A2A2B5"/>
+                </a:solidFill>
+                <a:latin typeface="Calibri" pitchFamily="34" charset="0"/>
+                <a:ea typeface="Calibri" pitchFamily="34" charset="-122"/>
+                <a:cs typeface="Calibri" pitchFamily="34" charset="-120"/>
+              </a:rPr>
+              <a:t>original son — yiliga</a:t>
+            </a:r>
+            <a:endParaRPr lang="en-US" sz="1150" dirty="0"/>
+          </a:p>
+        </p:txBody>
+      </p:sp>
+      <p:sp>
+        <p:nvSpPr>
+          <p:cNvPr id="10" name="Text 7"/>
+          <p:cNvSpPr/>
+          <p:nvPr/>
+        </p:nvSpPr>
+        <p:spPr>
+          <a:xfrm>
+            <a:off x="4846320" y="4206240"/>
+            <a:ext cx="1965960" cy="411480"/>
+          </a:xfrm>
+          <a:prstGeom prst="rect">
+            <a:avLst/>
+          </a:prstGeom>
+          <a:noFill/>
+          <a:ln/>
+        </p:spPr>
+        <p:txBody>
+          <a:bodyPr wrap="square" lIns="0" tIns="0" rIns="0" bIns="0" rtlCol="0" anchor="ctr"/>
+          <a:lstStyle/>
+          <a:p>
+            <a:pPr indent="0" marL="0">
+              <a:buNone/>
+            </a:pPr>
+            <a:r>
+              <a:rPr lang="en-US" sz="2200" b="1" dirty="0">
+                <a:solidFill>
+                  <a:srgbClr val="FFFFFF"/>
+                </a:solidFill>
+                <a:latin typeface="Arial" pitchFamily="34" charset="0"/>
+                <a:ea typeface="Arial" pitchFamily="34" charset="-122"/>
+                <a:cs typeface="Arial" pitchFamily="34" charset="-120"/>
+              </a:rPr>
+              <a:t>3,6 mln+</a:t>
+            </a:r>
+            <a:endParaRPr lang="en-US" sz="2200" dirty="0"/>
+          </a:p>
+        </p:txBody>
+      </p:sp>
+      <p:sp>
+        <p:nvSpPr>
+          <p:cNvPr id="11" name="Text 8"/>
+          <p:cNvSpPr/>
+          <p:nvPr/>
+        </p:nvSpPr>
+        <p:spPr>
+          <a:xfrm>
+            <a:off x="4846320" y="4617720"/>
+            <a:ext cx="1965960" cy="457200"/>
+          </a:xfrm>
+          <a:prstGeom prst="rect">
+            <a:avLst/>
+          </a:prstGeom>
+          <a:noFill/>
+          <a:ln/>
+        </p:spPr>
+        <p:txBody>
+          <a:bodyPr wrap="square" lIns="0" tIns="0" rIns="0" bIns="0" rtlCol="0" anchor="ctr"/>
+          <a:lstStyle/>
+          <a:p>
+            <a:pPr indent="0" marL="0">
+              <a:lnSpc>
+                <a:spcPts val="1500"/>
+              </a:lnSpc>
+              <a:buNone/>
+            </a:pPr>
+            <a:r>
+              <a:rPr lang="en-US" sz="1150" dirty="0">
+                <a:solidFill>
+                  <a:srgbClr val="A2A2B5"/>
+                </a:solidFill>
+                <a:latin typeface="Calibri" pitchFamily="34" charset="0"/>
+                <a:ea typeface="Calibri" pitchFamily="34" charset="-122"/>
+                <a:cs typeface="Calibri" pitchFamily="34" charset="-120"/>
+              </a:rPr>
+              <a:t>eng yuqori ko‘rish</a:t>
+            </a:r>
+            <a:endParaRPr lang="en-US" sz="1150" dirty="0"/>
+          </a:p>
+        </p:txBody>
+      </p:sp>
+      <p:sp>
+        <p:nvSpPr>
+          <p:cNvPr id="12" name="Shape 9"/>
+          <p:cNvSpPr/>
+          <p:nvPr/>
+        </p:nvSpPr>
+        <p:spPr>
+          <a:xfrm>
+            <a:off x="640080" y="5349240"/>
+            <a:ext cx="4434840" cy="868680"/>
           </a:xfrm>
           <a:prstGeom prst="roundRect">
             <a:avLst>
@@ -2637,13 +2853,13 @@
       </p:sp>
       <p:sp>
         <p:nvSpPr>
-          <p:cNvPr id="8" name="Shape 6"/>
-          <p:cNvSpPr/>
-          <p:nvPr/>
-        </p:nvSpPr>
-        <p:spPr>
-          <a:xfrm>
-            <a:off x="868680" y="4828032"/>
+          <p:cNvPr id="13" name="Shape 10"/>
+          <p:cNvSpPr/>
+          <p:nvPr/>
+        </p:nvSpPr>
+        <p:spPr>
+          <a:xfrm>
+            <a:off x="868680" y="5559552"/>
             <a:ext cx="457200" cy="457200"/>
           </a:xfrm>
           <a:prstGeom prst="ellipse">
@@ -2662,228 +2878,7 @@
       </p:sp>
       <p:pic>
         <p:nvPicPr>
-          <p:cNvPr id="9" name="Image 0" descr="preencoded.png">    </p:cNvPr>
-          <p:cNvPicPr>
-            <a:picLocks noChangeAspect="1"/>
-          </p:cNvPicPr>
-          <p:nvPr/>
-        </p:nvPicPr>
-        <p:blipFill>
-          <a:blip r:embed="rId1"/>
-          <a:stretch>
-            <a:fillRect/>
-          </a:stretch>
-        </p:blipFill>
-        <p:spPr>
-          <a:xfrm>
-            <a:off x="996696" y="4956048"/>
-            <a:ext cx="201168" cy="201168"/>
-          </a:xfrm>
-          <a:prstGeom prst="rect">
-            <a:avLst/>
-          </a:prstGeom>
-        </p:spPr>
-      </p:pic>
-      <p:sp>
-        <p:nvSpPr>
-          <p:cNvPr id="10" name="Text 7"/>
-          <p:cNvSpPr/>
-          <p:nvPr/>
-        </p:nvSpPr>
-        <p:spPr>
-          <a:xfrm>
-            <a:off x="1508760" y="4800600"/>
-            <a:ext cx="3108960" cy="256032"/>
-          </a:xfrm>
-          <a:prstGeom prst="rect">
-            <a:avLst/>
-          </a:prstGeom>
-          <a:noFill/>
-          <a:ln/>
-        </p:spPr>
-        <p:txBody>
-          <a:bodyPr wrap="square" lIns="0" tIns="0" rIns="0" bIns="0" rtlCol="0" anchor="ctr"/>
-          <a:lstStyle/>
-          <a:p>
-            <a:pPr indent="0" marL="0">
-              <a:buNone/>
-            </a:pPr>
-            <a:r>
-              <a:rPr lang="en-US" sz="1100" b="1" spc="200" kern="0" dirty="0">
-                <a:solidFill>
-                  <a:srgbClr val="FFC93C"/>
-                </a:solidFill>
-                <a:latin typeface="Arial" pitchFamily="34" charset="0"/>
-                <a:ea typeface="Arial" pitchFamily="34" charset="-122"/>
-                <a:cs typeface="Arial" pitchFamily="34" charset="-120"/>
-              </a:rPr>
-              <a:t>KOMMERSIYA TAKLIFI</a:t>
-            </a:r>
-            <a:endParaRPr lang="en-US" sz="1100" dirty="0"/>
-          </a:p>
-        </p:txBody>
-      </p:sp>
-      <p:sp>
-        <p:nvSpPr>
-          <p:cNvPr id="11" name="Text 8"/>
-          <p:cNvSpPr/>
-          <p:nvPr/>
-        </p:nvSpPr>
-        <p:spPr>
-          <a:xfrm>
-            <a:off x="1508760" y="5074920"/>
-            <a:ext cx="3108960" cy="274320"/>
-          </a:xfrm>
-          <a:prstGeom prst="rect">
-            <a:avLst/>
-          </a:prstGeom>
-          <a:noFill/>
-          <a:ln/>
-        </p:spPr>
-        <p:txBody>
-          <a:bodyPr wrap="square" lIns="0" tIns="0" rIns="0" bIns="0" rtlCol="0" anchor="ctr"/>
-          <a:lstStyle/>
-          <a:p>
-            <a:pPr indent="0" marL="0">
-              <a:lnSpc>
-                <a:spcPts val="1600"/>
-              </a:lnSpc>
-              <a:buNone/>
-            </a:pPr>
-            <a:r>
-              <a:rPr lang="en-US" sz="1300" dirty="0">
-                <a:solidFill>
-                  <a:srgbClr val="A2A2B5"/>
-                </a:solidFill>
-                <a:latin typeface="Calibri" pitchFamily="34" charset="0"/>
-                <a:ea typeface="Calibri" pitchFamily="34" charset="-122"/>
-                <a:cs typeface="Calibri" pitchFamily="34" charset="-120"/>
-              </a:rPr>
-              <a:t>Homiylik va hamkorlik dasturi</a:t>
-            </a:r>
-            <a:endParaRPr lang="en-US" sz="1300" dirty="0"/>
-          </a:p>
-        </p:txBody>
-      </p:sp>
-      <p:sp>
-        <p:nvSpPr>
-          <p:cNvPr id="12" name="Shape 9"/>
-          <p:cNvSpPr/>
-          <p:nvPr/>
-        </p:nvSpPr>
-        <p:spPr>
-          <a:xfrm>
-            <a:off x="7360920" y="1051560"/>
-            <a:ext cx="4187952" cy="4754880"/>
-          </a:xfrm>
-          <a:prstGeom prst="roundRect">
-            <a:avLst>
-              <a:gd name="adj" fmla="val 3057"/>
-            </a:avLst>
-          </a:prstGeom>
-          <a:solidFill>
-            <a:srgbClr val="191922"/>
-          </a:solidFill>
-          <a:ln w="9525">
-            <a:solidFill>
-              <a:srgbClr val="2E2E3D"/>
-            </a:solidFill>
-            <a:prstDash val="solid"/>
-          </a:ln>
-        </p:spPr>
-      </p:sp>
-      <p:sp>
-        <p:nvSpPr>
-          <p:cNvPr id="13" name="Shape 10"/>
-          <p:cNvSpPr/>
-          <p:nvPr/>
-        </p:nvSpPr>
-        <p:spPr>
-          <a:xfrm>
-            <a:off x="7726680" y="1417320"/>
-            <a:ext cx="201168" cy="201168"/>
-          </a:xfrm>
-          <a:prstGeom prst="ellipse">
-            <a:avLst/>
-          </a:prstGeom>
-          <a:solidFill>
-            <a:srgbClr val="FF3B47"/>
-          </a:solidFill>
-          <a:ln w="6350">
-            <a:solidFill>
-              <a:srgbClr val="FF3B47"/>
-            </a:solidFill>
-            <a:prstDash val="solid"/>
-          </a:ln>
-        </p:spPr>
-      </p:sp>
-      <p:sp>
-        <p:nvSpPr>
-          <p:cNvPr id="14" name="Text 11"/>
-          <p:cNvSpPr/>
-          <p:nvPr/>
-        </p:nvSpPr>
-        <p:spPr>
-          <a:xfrm>
-            <a:off x="8001000" y="1371600"/>
-            <a:ext cx="1097280" cy="274320"/>
-          </a:xfrm>
-          <a:prstGeom prst="rect">
-            <a:avLst/>
-          </a:prstGeom>
-          <a:noFill/>
-          <a:ln/>
-        </p:spPr>
-        <p:txBody>
-          <a:bodyPr wrap="square" lIns="0" tIns="0" rIns="0" bIns="0" rtlCol="0" anchor="ctr"/>
-          <a:lstStyle/>
-          <a:p>
-            <a:pPr indent="0" marL="0">
-              <a:buNone/>
-            </a:pPr>
-            <a:r>
-              <a:rPr lang="en-US" sz="1200" b="1" spc="200" kern="0" dirty="0">
-                <a:solidFill>
-                  <a:srgbClr val="FF3B47"/>
-                </a:solidFill>
-                <a:latin typeface="Arial" pitchFamily="34" charset="0"/>
-                <a:ea typeface="Arial" pitchFamily="34" charset="-122"/>
-                <a:cs typeface="Arial" pitchFamily="34" charset="-120"/>
-              </a:rPr>
-              <a:t>REC</a:t>
-            </a:r>
-            <a:endParaRPr lang="en-US" sz="1200" dirty="0"/>
-          </a:p>
-        </p:txBody>
-      </p:sp>
-      <p:sp>
-        <p:nvSpPr>
-          <p:cNvPr id="15" name="Shape 12"/>
-          <p:cNvSpPr/>
-          <p:nvPr/>
-        </p:nvSpPr>
-        <p:spPr>
-          <a:xfrm>
-            <a:off x="9006840" y="2148840"/>
-            <a:ext cx="914400" cy="914400"/>
-          </a:xfrm>
-          <a:prstGeom prst="ellipse">
-            <a:avLst/>
-          </a:prstGeom>
-          <a:solidFill>
-            <a:srgbClr val="212130"/>
-          </a:solidFill>
-          <a:ln w="12700">
-            <a:solidFill>
-              <a:srgbClr val="2E2E3D"/>
-            </a:solidFill>
-            <a:prstDash val="solid"/>
-          </a:ln>
-        </p:spPr>
-      </p:sp>
-      <p:pic>
-        <p:nvPicPr>
-          <p:cNvPr id="16" name="Image 1" descr="preencoded.png">    </p:cNvPr>
+          <p:cNvPr id="14" name="Image 1" descr="preencoded.png">    </p:cNvPr>
           <p:cNvPicPr>
             <a:picLocks noChangeAspect="1"/>
           </p:cNvPicPr>
@@ -2897,8 +2892,8 @@
         </p:blipFill>
         <p:spPr>
           <a:xfrm>
-            <a:off x="9235440" y="2377440"/>
-            <a:ext cx="457200" cy="457200"/>
+            <a:off x="996696" y="5687568"/>
+            <a:ext cx="201168" cy="201168"/>
           </a:xfrm>
           <a:prstGeom prst="rect">
             <a:avLst/>
@@ -2907,72 +2902,72 @@
       </p:pic>
       <p:sp>
         <p:nvSpPr>
-          <p:cNvPr id="17" name="Text 13"/>
-          <p:cNvSpPr/>
-          <p:nvPr/>
-        </p:nvSpPr>
-        <p:spPr>
-          <a:xfrm>
-            <a:off x="7726680" y="3429000"/>
-            <a:ext cx="1737360" cy="365760"/>
-          </a:xfrm>
-          <a:prstGeom prst="rect">
-            <a:avLst/>
-          </a:prstGeom>
-          <a:noFill/>
-          <a:ln/>
-        </p:spPr>
-        <p:txBody>
-          <a:bodyPr wrap="square" lIns="0" tIns="0" rIns="0" bIns="0" rtlCol="0" anchor="ctr"/>
-          <a:lstStyle/>
-          <a:p>
-            <a:pPr indent="0" marL="0">
-              <a:buNone/>
-            </a:pPr>
-            <a:r>
-              <a:rPr lang="en-US" sz="2000" b="1" dirty="0">
-                <a:solidFill>
-                  <a:srgbClr val="FFFFFF"/>
+          <p:cNvPr id="15" name="Text 11"/>
+          <p:cNvSpPr/>
+          <p:nvPr/>
+        </p:nvSpPr>
+        <p:spPr>
+          <a:xfrm>
+            <a:off x="1508760" y="5532120"/>
+            <a:ext cx="3383280" cy="256032"/>
+          </a:xfrm>
+          <a:prstGeom prst="rect">
+            <a:avLst/>
+          </a:prstGeom>
+          <a:noFill/>
+          <a:ln/>
+        </p:spPr>
+        <p:txBody>
+          <a:bodyPr wrap="square" lIns="0" tIns="0" rIns="0" bIns="0" rtlCol="0" anchor="ctr"/>
+          <a:lstStyle/>
+          <a:p>
+            <a:pPr indent="0" marL="0">
+              <a:buNone/>
+            </a:pPr>
+            <a:r>
+              <a:rPr lang="en-US" sz="1100" b="1" spc="200" kern="0" dirty="0">
+                <a:solidFill>
+                  <a:srgbClr val="FFC93C"/>
                 </a:solidFill>
                 <a:latin typeface="Arial" pitchFamily="34" charset="0"/>
                 <a:ea typeface="Arial" pitchFamily="34" charset="-122"/>
                 <a:cs typeface="Arial" pitchFamily="34" charset="-120"/>
               </a:rPr>
-              <a:t>62 400+</a:t>
-            </a:r>
-            <a:endParaRPr lang="en-US" sz="2000" dirty="0"/>
-          </a:p>
-        </p:txBody>
-      </p:sp>
-      <p:sp>
-        <p:nvSpPr>
-          <p:cNvPr id="18" name="Text 14"/>
-          <p:cNvSpPr/>
-          <p:nvPr/>
-        </p:nvSpPr>
-        <p:spPr>
-          <a:xfrm>
-            <a:off x="9464040" y="3483864"/>
-            <a:ext cx="1828800" cy="292608"/>
-          </a:xfrm>
-          <a:prstGeom prst="rect">
-            <a:avLst/>
-          </a:prstGeom>
-          <a:noFill/>
-          <a:ln/>
-        </p:spPr>
-        <p:txBody>
-          <a:bodyPr wrap="square" lIns="0" tIns="0" rIns="0" bIns="0" rtlCol="0" anchor="ctr"/>
-          <a:lstStyle/>
-          <a:p>
-            <a:pPr algn="r" indent="0" marL="0">
+              <a:t>KOMMERSIYA TAKLIFI</a:t>
+            </a:r>
+            <a:endParaRPr lang="en-US" sz="1100" dirty="0"/>
+          </a:p>
+        </p:txBody>
+      </p:sp>
+      <p:sp>
+        <p:nvSpPr>
+          <p:cNvPr id="16" name="Text 12"/>
+          <p:cNvSpPr/>
+          <p:nvPr/>
+        </p:nvSpPr>
+        <p:spPr>
+          <a:xfrm>
+            <a:off x="1508760" y="5806440"/>
+            <a:ext cx="3383280" cy="274320"/>
+          </a:xfrm>
+          <a:prstGeom prst="rect">
+            <a:avLst/>
+          </a:prstGeom>
+          <a:noFill/>
+          <a:ln/>
+        </p:spPr>
+        <p:txBody>
+          <a:bodyPr wrap="square" lIns="0" tIns="0" rIns="0" bIns="0" rtlCol="0" anchor="ctr"/>
+          <a:lstStyle/>
+          <a:p>
+            <a:pPr indent="0" marL="0">
               <a:lnSpc>
-                <a:spcPts val="1400"/>
+                <a:spcPts val="1600"/>
               </a:lnSpc>
               <a:buNone/>
             </a:pPr>
             <a:r>
-              <a:rPr lang="en-US" sz="1200" dirty="0">
+              <a:rPr lang="en-US" sz="1300" dirty="0">
                 <a:solidFill>
                   <a:srgbClr val="A2A2B5"/>
                 </a:solidFill>
@@ -2980,221 +2975,9 @@
                 <a:ea typeface="Calibri" pitchFamily="34" charset="-122"/>
                 <a:cs typeface="Calibri" pitchFamily="34" charset="-120"/>
               </a:rPr>
-              <a:t>YouTube obunachi</a:t>
-            </a:r>
-            <a:endParaRPr lang="en-US" sz="1200" dirty="0"/>
-          </a:p>
-        </p:txBody>
-      </p:sp>
-      <p:sp>
-        <p:nvSpPr>
-          <p:cNvPr id="19" name="Shape 15"/>
-          <p:cNvSpPr/>
-          <p:nvPr/>
-        </p:nvSpPr>
-        <p:spPr>
-          <a:xfrm>
-            <a:off x="7726680" y="3959352"/>
-            <a:ext cx="3566160" cy="9144"/>
-          </a:xfrm>
-          <a:prstGeom prst="rect">
-            <a:avLst/>
-          </a:prstGeom>
-          <a:solidFill>
-            <a:srgbClr val="2E2E3D"/>
-          </a:solidFill>
-          <a:ln w="6350">
-            <a:solidFill>
-              <a:srgbClr val="2E2E3D"/>
-            </a:solidFill>
-            <a:prstDash val="solid"/>
-          </a:ln>
-        </p:spPr>
-      </p:sp>
-      <p:sp>
-        <p:nvSpPr>
-          <p:cNvPr id="20" name="Text 16"/>
-          <p:cNvSpPr/>
-          <p:nvPr/>
-        </p:nvSpPr>
-        <p:spPr>
-          <a:xfrm>
-            <a:off x="7726680" y="4206240"/>
-            <a:ext cx="1737360" cy="365760"/>
-          </a:xfrm>
-          <a:prstGeom prst="rect">
-            <a:avLst/>
-          </a:prstGeom>
-          <a:noFill/>
-          <a:ln/>
-        </p:spPr>
-        <p:txBody>
-          <a:bodyPr wrap="square" lIns="0" tIns="0" rIns="0" bIns="0" rtlCol="0" anchor="ctr"/>
-          <a:lstStyle/>
-          <a:p>
-            <a:pPr indent="0" marL="0">
-              <a:buNone/>
-            </a:pPr>
-            <a:r>
-              <a:rPr lang="en-US" sz="2000" b="1" dirty="0">
-                <a:solidFill>
-                  <a:srgbClr val="FFFFFF"/>
-                </a:solidFill>
-                <a:latin typeface="Arial" pitchFamily="34" charset="0"/>
-                <a:ea typeface="Arial" pitchFamily="34" charset="-122"/>
-                <a:cs typeface="Arial" pitchFamily="34" charset="-120"/>
-              </a:rPr>
-              <a:t>3,6 mln+</a:t>
-            </a:r>
-            <a:endParaRPr lang="en-US" sz="2000" dirty="0"/>
-          </a:p>
-        </p:txBody>
-      </p:sp>
-      <p:sp>
-        <p:nvSpPr>
-          <p:cNvPr id="21" name="Text 17"/>
-          <p:cNvSpPr/>
-          <p:nvPr/>
-        </p:nvSpPr>
-        <p:spPr>
-          <a:xfrm>
-            <a:off x="9464040" y="4261104"/>
-            <a:ext cx="1828800" cy="292608"/>
-          </a:xfrm>
-          <a:prstGeom prst="rect">
-            <a:avLst/>
-          </a:prstGeom>
-          <a:noFill/>
-          <a:ln/>
-        </p:spPr>
-        <p:txBody>
-          <a:bodyPr wrap="square" lIns="0" tIns="0" rIns="0" bIns="0" rtlCol="0" anchor="ctr"/>
-          <a:lstStyle/>
-          <a:p>
-            <a:pPr algn="r" indent="0" marL="0">
-              <a:lnSpc>
-                <a:spcPts val="1400"/>
-              </a:lnSpc>
-              <a:buNone/>
-            </a:pPr>
-            <a:r>
-              <a:rPr lang="en-US" sz="1200" dirty="0">
-                <a:solidFill>
-                  <a:srgbClr val="A2A2B5"/>
-                </a:solidFill>
-                <a:latin typeface="Calibri" pitchFamily="34" charset="0"/>
-                <a:ea typeface="Calibri" pitchFamily="34" charset="-122"/>
-                <a:cs typeface="Calibri" pitchFamily="34" charset="-120"/>
-              </a:rPr>
-              <a:t>eng yuqori ko‘rish</a:t>
-            </a:r>
-            <a:endParaRPr lang="en-US" sz="1200" dirty="0"/>
-          </a:p>
-        </p:txBody>
-      </p:sp>
-      <p:sp>
-        <p:nvSpPr>
-          <p:cNvPr id="22" name="Shape 18"/>
-          <p:cNvSpPr/>
-          <p:nvPr/>
-        </p:nvSpPr>
-        <p:spPr>
-          <a:xfrm>
-            <a:off x="7726680" y="4736592"/>
-            <a:ext cx="3566160" cy="9144"/>
-          </a:xfrm>
-          <a:prstGeom prst="rect">
-            <a:avLst/>
-          </a:prstGeom>
-          <a:solidFill>
-            <a:srgbClr val="2E2E3D"/>
-          </a:solidFill>
-          <a:ln w="6350">
-            <a:solidFill>
-              <a:srgbClr val="2E2E3D"/>
-            </a:solidFill>
-            <a:prstDash val="solid"/>
-          </a:ln>
-        </p:spPr>
-      </p:sp>
-      <p:sp>
-        <p:nvSpPr>
-          <p:cNvPr id="23" name="Text 19"/>
-          <p:cNvSpPr/>
-          <p:nvPr/>
-        </p:nvSpPr>
-        <p:spPr>
-          <a:xfrm>
-            <a:off x="7726680" y="4983480"/>
-            <a:ext cx="1737360" cy="365760"/>
-          </a:xfrm>
-          <a:prstGeom prst="rect">
-            <a:avLst/>
-          </a:prstGeom>
-          <a:noFill/>
-          <a:ln/>
-        </p:spPr>
-        <p:txBody>
-          <a:bodyPr wrap="square" lIns="0" tIns="0" rIns="0" bIns="0" rtlCol="0" anchor="ctr"/>
-          <a:lstStyle/>
-          <a:p>
-            <a:pPr indent="0" marL="0">
-              <a:buNone/>
-            </a:pPr>
-            <a:r>
-              <a:rPr lang="en-US" sz="2000" b="1" dirty="0">
-                <a:solidFill>
-                  <a:srgbClr val="FFFFFF"/>
-                </a:solidFill>
-                <a:latin typeface="Arial" pitchFamily="34" charset="0"/>
-                <a:ea typeface="Arial" pitchFamily="34" charset="-122"/>
-                <a:cs typeface="Arial" pitchFamily="34" charset="-120"/>
-              </a:rPr>
-              <a:t>48</a:t>
-            </a:r>
-            <a:endParaRPr lang="en-US" sz="2000" dirty="0"/>
-          </a:p>
-        </p:txBody>
-      </p:sp>
-      <p:sp>
-        <p:nvSpPr>
-          <p:cNvPr id="24" name="Text 20"/>
-          <p:cNvSpPr/>
-          <p:nvPr/>
-        </p:nvSpPr>
-        <p:spPr>
-          <a:xfrm>
-            <a:off x="9464040" y="5038344"/>
-            <a:ext cx="1828800" cy="292608"/>
-          </a:xfrm>
-          <a:prstGeom prst="rect">
-            <a:avLst/>
-          </a:prstGeom>
-          <a:noFill/>
-          <a:ln/>
-        </p:spPr>
-        <p:txBody>
-          <a:bodyPr wrap="square" lIns="0" tIns="0" rIns="0" bIns="0" rtlCol="0" anchor="ctr"/>
-          <a:lstStyle/>
-          <a:p>
-            <a:pPr algn="r" indent="0" marL="0">
-              <a:lnSpc>
-                <a:spcPts val="1400"/>
-              </a:lnSpc>
-              <a:buNone/>
-            </a:pPr>
-            <a:r>
-              <a:rPr lang="en-US" sz="1200" dirty="0">
-                <a:solidFill>
-                  <a:srgbClr val="A2A2B5"/>
-                </a:solidFill>
-                <a:latin typeface="Calibri" pitchFamily="34" charset="0"/>
-                <a:ea typeface="Calibri" pitchFamily="34" charset="-122"/>
-                <a:cs typeface="Calibri" pitchFamily="34" charset="-120"/>
-              </a:rPr>
-              <a:t>original son — yiliga</a:t>
-            </a:r>
-            <a:endParaRPr lang="en-US" sz="1200" dirty="0"/>
+              <a:t>Homiylik va hamkorlik dasturi</a:t>
+            </a:r>
+            <a:endParaRPr lang="en-US" sz="1300" dirty="0"/>
           </a:p>
         </p:txBody>
       </p:sp>
@@ -3853,7 +3636,7 @@
     <p:bg>
       <p:bgPr>
         <a:solidFill>
-          <a:srgbClr val="FF3B47"/>
+          <a:srgbClr val="0D0D14"/>
         </a:solidFill>
       </p:bgPr>
     </p:bg>
@@ -3871,26 +3654,51 @@
           <a:chExt cx="0" cy="0"/>
         </a:xfrm>
       </p:grpSpPr>
-      <p:sp>
-        <p:nvSpPr>
-          <p:cNvPr id="2" name="Shape 0"/>
-          <p:cNvSpPr/>
-          <p:nvPr/>
-        </p:nvSpPr>
-        <p:spPr>
-          <a:xfrm>
-            <a:off x="-1463040" y="-2011680"/>
-            <a:ext cx="6035040" cy="6035040"/>
-          </a:xfrm>
-          <a:prstGeom prst="ellipse">
+      <p:pic>
+        <p:nvPicPr>
+          <p:cNvPr id="2" name="Image 0" descr="assets/banner.jpg">    </p:cNvPr>
+          <p:cNvPicPr>
+            <a:picLocks noChangeAspect="1"/>
+          </p:cNvPicPr>
+          <p:nvPr/>
+        </p:nvPicPr>
+        <p:blipFill>
+          <a:blip r:embed="rId1"/>
+          <a:srcRect l="0" r="0" t="0" b="0"/>
+          <a:stretch/>
+        </p:blipFill>
+        <p:spPr>
+          <a:xfrm>
+            <a:off x="0" y="0"/>
+            <a:ext cx="12191695" cy="6858000"/>
+          </a:xfrm>
+          <a:prstGeom prst="rect">
+            <a:avLst/>
+          </a:prstGeom>
+        </p:spPr>
+      </p:pic>
+      <p:sp>
+        <p:nvSpPr>
+          <p:cNvPr id="3" name="Shape 0"/>
+          <p:cNvSpPr/>
+          <p:nvPr/>
+        </p:nvSpPr>
+        <p:spPr>
+          <a:xfrm>
+            <a:off x="0" y="0"/>
+            <a:ext cx="12191695" cy="6858000"/>
+          </a:xfrm>
+          <a:prstGeom prst="rect">
             <a:avLst/>
           </a:prstGeom>
           <a:solidFill>
-            <a:srgbClr val="FF3B47"/>
+            <a:srgbClr val="0D0D14">
+              <a:alpha val="84000"/>
+            </a:srgbClr>
           </a:solidFill>
-          <a:ln w="15875">
+          <a:ln w="6350">
             <a:solidFill>
-              <a:srgbClr val="D42130"/>
+              <a:srgbClr val="0D0D14"/>
             </a:solidFill>
             <a:prstDash val="solid"/>
           </a:ln>
@@ -3898,32 +3706,7 @@
       </p:sp>
       <p:sp>
         <p:nvSpPr>
-          <p:cNvPr id="3" name="Shape 1"/>
-          <p:cNvSpPr/>
-          <p:nvPr/>
-        </p:nvSpPr>
-        <p:spPr>
-          <a:xfrm>
-            <a:off x="8412480" y="2926080"/>
-            <a:ext cx="5852160" cy="5852160"/>
-          </a:xfrm>
-          <a:prstGeom prst="ellipse">
-            <a:avLst/>
-          </a:prstGeom>
-          <a:solidFill>
-            <a:srgbClr val="FF3B47"/>
-          </a:solidFill>
-          <a:ln w="15875">
-            <a:solidFill>
-              <a:srgbClr val="D42130"/>
-            </a:solidFill>
-            <a:prstDash val="solid"/>
-          </a:ln>
-        </p:spPr>
-      </p:sp>
-      <p:sp>
-        <p:nvSpPr>
-          <p:cNvPr id="4" name="Text 2"/>
+          <p:cNvPr id="4" name="Text 1"/>
           <p:cNvSpPr/>
           <p:nvPr/>
         </p:nvSpPr>
@@ -3948,7 +3731,7 @@
             <a:r>
               <a:rPr lang="en-US" sz="1200" b="1" spc="350" kern="0" dirty="0">
                 <a:solidFill>
-                  <a:srgbClr val="FFE0E2"/>
+                  <a:srgbClr val="FFC93C"/>
                 </a:solidFill>
                 <a:latin typeface="Arial" pitchFamily="34" charset="0"/>
                 <a:ea typeface="Arial" pitchFamily="34" charset="-122"/>
@@ -3962,7 +3745,7 @@
       </p:sp>
       <p:sp>
         <p:nvSpPr>
-          <p:cNvPr id="5" name="Text 3"/>
+          <p:cNvPr id="5" name="Text 2"/>
           <p:cNvSpPr/>
           <p:nvPr/>
         </p:nvSpPr>
@@ -4024,7 +3807,7 @@
       </p:sp>
       <p:sp>
         <p:nvSpPr>
-          <p:cNvPr id="6" name="Text 4"/>
+          <p:cNvPr id="6" name="Text 3"/>
           <p:cNvSpPr/>
           <p:nvPr/>
         </p:nvSpPr>
@@ -4049,7 +3832,7 @@
             <a:r>
               <a:rPr lang="en-US" sz="1700" dirty="0">
                 <a:solidFill>
-                  <a:srgbClr val="FFE9EA"/>
+                  <a:srgbClr val="F0F0F5"/>
                 </a:solidFill>
                 <a:latin typeface="Calibri" pitchFamily="34" charset="0"/>
                 <a:ea typeface="Calibri" pitchFamily="34" charset="-122"/>
@@ -4063,7 +3846,7 @@
       </p:sp>
       <p:sp>
         <p:nvSpPr>
-          <p:cNvPr id="7" name="Shape 5"/>
+          <p:cNvPr id="7" name="Shape 4"/>
           <p:cNvSpPr/>
           <p:nvPr/>
         </p:nvSpPr>
@@ -4078,11 +3861,11 @@
             </a:avLst>
           </a:prstGeom>
           <a:solidFill>
-            <a:srgbClr val="FFFFFF"/>
+            <a:srgbClr val="FF3B47"/>
           </a:solidFill>
           <a:ln w="9525">
             <a:solidFill>
-              <a:srgbClr val="FFFFFF"/>
+              <a:srgbClr val="FF3B47"/>
             </a:solidFill>
             <a:prstDash val="solid"/>
           </a:ln>
@@ -4090,7 +3873,7 @@
       </p:sp>
       <p:sp>
         <p:nvSpPr>
-          <p:cNvPr id="8" name="Text 6"/>
+          <p:cNvPr id="8" name="Text 5"/>
           <p:cNvSpPr/>
           <p:nvPr/>
         </p:nvSpPr>
@@ -4115,7 +3898,7 @@
             <a:r>
               <a:rPr lang="en-US" sz="1300" b="1" spc="200" kern="0" dirty="0">
                 <a:solidFill>
-                  <a:srgbClr val="D42130"/>
+                  <a:srgbClr val="FFFFFF"/>
                 </a:solidFill>
                 <a:latin typeface="Arial" pitchFamily="34" charset="0"/>
                 <a:ea typeface="Arial" pitchFamily="34" charset="-122"/>
@@ -4184,16 +3967,39 @@
           </a:ln>
         </p:spPr>
       </p:sp>
-      <p:sp>
-        <p:nvSpPr>
-          <p:cNvPr id="3" name="Text 1"/>
-          <p:cNvSpPr/>
-          <p:nvPr/>
-        </p:nvSpPr>
+      <p:pic>
+        <p:nvPicPr>
+          <p:cNvPr id="3" name="Image 0" descr="assets/logo.jpg">    </p:cNvPr>
+          <p:cNvPicPr>
+            <a:picLocks noChangeAspect="1"/>
+          </p:cNvPicPr>
+          <p:nvPr/>
+        </p:nvPicPr>
+        <p:blipFill>
+          <a:blip r:embed="rId1"/>
+          <a:srcRect l="0" r="0" t="0" b="0"/>
+          <a:stretch/>
+        </p:blipFill>
         <p:spPr>
           <a:xfrm>
             <a:off x="640080" y="1371600"/>
-            <a:ext cx="6400800" cy="292608"/>
+            <a:ext cx="3154680" cy="3154680"/>
+          </a:xfrm>
+          <a:prstGeom prst="rect">
+            <a:avLst/>
+          </a:prstGeom>
+        </p:spPr>
+      </p:pic>
+      <p:sp>
+        <p:nvSpPr>
+          <p:cNvPr id="4" name="Text 1"/>
+          <p:cNvSpPr/>
+          <p:nvPr/>
+        </p:nvSpPr>
+        <p:spPr>
+          <a:xfrm>
+            <a:off x="640080" y="4754880"/>
+            <a:ext cx="5120640" cy="292608"/>
           </a:xfrm>
           <a:prstGeom prst="rect">
             <a:avLst/>
@@ -4225,76 +4031,14 @@
       </p:sp>
       <p:sp>
         <p:nvSpPr>
-          <p:cNvPr id="4" name="Text 2"/>
-          <p:cNvSpPr/>
-          <p:nvPr/>
-        </p:nvSpPr>
-        <p:spPr>
-          <a:xfrm>
-            <a:off x="640080" y="1783080"/>
-            <a:ext cx="5943600" cy="1554480"/>
-          </a:xfrm>
-          <a:prstGeom prst="rect">
-            <a:avLst/>
-          </a:prstGeom>
-          <a:noFill/>
-          <a:ln/>
-        </p:spPr>
-        <p:txBody>
-          <a:bodyPr wrap="square" lIns="0" tIns="0" rIns="0" bIns="0" rtlCol="0" anchor="ctr"/>
-          <a:lstStyle/>
-          <a:p>
-            <a:pPr indent="0" marL="0">
-              <a:lnSpc>
-                <a:spcPts val="4400"/>
-              </a:lnSpc>
-              <a:buNone/>
-            </a:pPr>
-            <a:r>
-              <a:rPr lang="en-US" sz="3800" b="1" dirty="0">
-                <a:solidFill>
-                  <a:srgbClr val="FFFFFF"/>
-                </a:solidFill>
-                <a:latin typeface="Arial" pitchFamily="34" charset="0"/>
-                <a:ea typeface="Arial" pitchFamily="34" charset="-122"/>
-                <a:cs typeface="Arial" pitchFamily="34" charset="-120"/>
-              </a:rPr>
-              <a:t>SHUNAQASI HAM</a:t>
-            </a:r>
-            <a:endParaRPr lang="en-US" sz="3800" dirty="0"/>
-          </a:p>
-          <a:p>
-            <a:pPr indent="0" marL="0">
-              <a:lnSpc>
-                <a:spcPts val="4400"/>
-              </a:lnSpc>
-              <a:buNone/>
-            </a:pPr>
-            <a:r>
-              <a:rPr lang="en-US" sz="3800" b="1" dirty="0">
-                <a:solidFill>
-                  <a:srgbClr val="FFFFFF"/>
-                </a:solidFill>
-                <a:latin typeface="Arial" pitchFamily="34" charset="0"/>
-                <a:ea typeface="Arial" pitchFamily="34" charset="-122"/>
-                <a:cs typeface="Arial" pitchFamily="34" charset="-120"/>
-              </a:rPr>
-              <a:t>BO‘P TURADI</a:t>
-            </a:r>
-            <a:endParaRPr lang="en-US" sz="3800" dirty="0"/>
-          </a:p>
-        </p:txBody>
-      </p:sp>
-      <p:sp>
-        <p:nvSpPr>
-          <p:cNvPr id="5" name="Text 3"/>
-          <p:cNvSpPr/>
-          <p:nvPr/>
-        </p:nvSpPr>
-        <p:spPr>
-          <a:xfrm>
-            <a:off x="640080" y="3429000"/>
-            <a:ext cx="5120640" cy="731520"/>
+          <p:cNvPr id="5" name="Text 2"/>
+          <p:cNvSpPr/>
+          <p:nvPr/>
+        </p:nvSpPr>
+        <p:spPr>
+          <a:xfrm>
+            <a:off x="640080" y="5120640"/>
+            <a:ext cx="5120640" cy="777240"/>
           </a:xfrm>
           <a:prstGeom prst="rect">
             <a:avLst/>
@@ -4329,7 +4073,7 @@
       </p:sp>
       <p:sp>
         <p:nvSpPr>
-          <p:cNvPr id="6" name="Shape 4"/>
+          <p:cNvPr id="6" name="Shape 3"/>
           <p:cNvSpPr/>
           <p:nvPr/>
         </p:nvSpPr>
@@ -4356,7 +4100,7 @@
       </p:sp>
       <p:sp>
         <p:nvSpPr>
-          <p:cNvPr id="7" name="Shape 5"/>
+          <p:cNvPr id="7" name="Shape 4"/>
           <p:cNvSpPr/>
           <p:nvPr/>
         </p:nvSpPr>
@@ -4381,14 +4125,14 @@
       </p:sp>
       <p:pic>
         <p:nvPicPr>
-          <p:cNvPr id="8" name="Image 0" descr="preencoded.png">    </p:cNvPr>
+          <p:cNvPr id="8" name="Image 1" descr="preencoded.png">    </p:cNvPr>
           <p:cNvPicPr>
             <a:picLocks noChangeAspect="1"/>
           </p:cNvPicPr>
           <p:nvPr/>
         </p:nvPicPr>
         <p:blipFill>
-          <a:blip r:embed="rId1"/>
+          <a:blip r:embed="rId2"/>
           <a:stretch>
             <a:fillRect/>
           </a:stretch>
@@ -4405,7 +4149,7 @@
       </p:pic>
       <p:sp>
         <p:nvSpPr>
-          <p:cNvPr id="9" name="Text 6"/>
+          <p:cNvPr id="9" name="Text 5"/>
           <p:cNvSpPr/>
           <p:nvPr/>
         </p:nvSpPr>
@@ -4444,7 +4188,7 @@
       </p:sp>
       <p:sp>
         <p:nvSpPr>
-          <p:cNvPr id="10" name="Text 7"/>
+          <p:cNvPr id="10" name="Text 6"/>
           <p:cNvSpPr/>
           <p:nvPr/>
         </p:nvSpPr>
@@ -4486,7 +4230,7 @@
       </p:sp>
       <p:sp>
         <p:nvSpPr>
-          <p:cNvPr id="11" name="Shape 8"/>
+          <p:cNvPr id="11" name="Shape 7"/>
           <p:cNvSpPr/>
           <p:nvPr/>
         </p:nvSpPr>
@@ -4511,7 +4255,7 @@
       </p:sp>
       <p:sp>
         <p:nvSpPr>
-          <p:cNvPr id="12" name="Shape 9"/>
+          <p:cNvPr id="12" name="Shape 8"/>
           <p:cNvSpPr/>
           <p:nvPr/>
         </p:nvSpPr>
@@ -4536,14 +4280,14 @@
       </p:sp>
       <p:pic>
         <p:nvPicPr>
-          <p:cNvPr id="13" name="Image 1" descr="preencoded.png">    </p:cNvPr>
+          <p:cNvPr id="13" name="Image 2" descr="preencoded.png">    </p:cNvPr>
           <p:cNvPicPr>
             <a:picLocks noChangeAspect="1"/>
           </p:cNvPicPr>
           <p:nvPr/>
         </p:nvPicPr>
         <p:blipFill>
-          <a:blip r:embed="rId2"/>
+          <a:blip r:embed="rId3"/>
           <a:stretch>
             <a:fillRect/>
           </a:stretch>
@@ -4560,7 +4304,7 @@
       </p:pic>
       <p:sp>
         <p:nvSpPr>
-          <p:cNvPr id="14" name="Text 10"/>
+          <p:cNvPr id="14" name="Text 9"/>
           <p:cNvSpPr/>
           <p:nvPr/>
         </p:nvSpPr>
@@ -4599,7 +4343,7 @@
       </p:sp>
       <p:sp>
         <p:nvSpPr>
-          <p:cNvPr id="15" name="Text 11"/>
+          <p:cNvPr id="15" name="Text 10"/>
           <p:cNvSpPr/>
           <p:nvPr/>
         </p:nvSpPr>
@@ -4641,7 +4385,7 @@
       </p:sp>
       <p:sp>
         <p:nvSpPr>
-          <p:cNvPr id="16" name="Shape 12"/>
+          <p:cNvPr id="16" name="Shape 11"/>
           <p:cNvSpPr/>
           <p:nvPr/>
         </p:nvSpPr>
@@ -4666,7 +4410,7 @@
       </p:sp>
       <p:sp>
         <p:nvSpPr>
-          <p:cNvPr id="17" name="Shape 13"/>
+          <p:cNvPr id="17" name="Shape 12"/>
           <p:cNvSpPr/>
           <p:nvPr/>
         </p:nvSpPr>
@@ -4691,14 +4435,14 @@
       </p:sp>
       <p:pic>
         <p:nvPicPr>
-          <p:cNvPr id="18" name="Image 2" descr="preencoded.png">    </p:cNvPr>
+          <p:cNvPr id="18" name="Image 3" descr="preencoded.png">    </p:cNvPr>
           <p:cNvPicPr>
             <a:picLocks noChangeAspect="1"/>
           </p:cNvPicPr>
           <p:nvPr/>
         </p:nvPicPr>
         <p:blipFill>
-          <a:blip r:embed="rId3"/>
+          <a:blip r:embed="rId4"/>
           <a:stretch>
             <a:fillRect/>
           </a:stretch>
@@ -4715,7 +4459,7 @@
       </p:pic>
       <p:sp>
         <p:nvSpPr>
-          <p:cNvPr id="19" name="Text 14"/>
+          <p:cNvPr id="19" name="Text 13"/>
           <p:cNvSpPr/>
           <p:nvPr/>
         </p:nvSpPr>
@@ -4754,7 +4498,7 @@
       </p:sp>
       <p:sp>
         <p:nvSpPr>
-          <p:cNvPr id="20" name="Text 15"/>
+          <p:cNvPr id="20" name="Text 14"/>
           <p:cNvSpPr/>
           <p:nvPr/>
         </p:nvSpPr>
@@ -4796,7 +4540,7 @@
       </p:sp>
       <p:sp>
         <p:nvSpPr>
-          <p:cNvPr id="21" name="Shape 16"/>
+          <p:cNvPr id="21" name="Shape 15"/>
           <p:cNvSpPr/>
           <p:nvPr/>
         </p:nvSpPr>
@@ -4821,7 +4565,7 @@
       </p:sp>
       <p:sp>
         <p:nvSpPr>
-          <p:cNvPr id="22" name="Shape 17"/>
+          <p:cNvPr id="22" name="Shape 16"/>
           <p:cNvSpPr/>
           <p:nvPr/>
         </p:nvSpPr>
@@ -4846,14 +4590,14 @@
       </p:sp>
       <p:pic>
         <p:nvPicPr>
-          <p:cNvPr id="23" name="Image 3" descr="preencoded.png">    </p:cNvPr>
+          <p:cNvPr id="23" name="Image 4" descr="preencoded.png">    </p:cNvPr>
           <p:cNvPicPr>
             <a:picLocks noChangeAspect="1"/>
           </p:cNvPicPr>
           <p:nvPr/>
         </p:nvPicPr>
         <p:blipFill>
-          <a:blip r:embed="rId4"/>
+          <a:blip r:embed="rId5"/>
           <a:stretch>
             <a:fillRect/>
           </a:stretch>
@@ -4870,7 +4614,7 @@
       </p:pic>
       <p:sp>
         <p:nvSpPr>
-          <p:cNvPr id="24" name="Text 18"/>
+          <p:cNvPr id="24" name="Text 17"/>
           <p:cNvSpPr/>
           <p:nvPr/>
         </p:nvSpPr>
@@ -4909,7 +4653,7 @@
       </p:sp>
       <p:sp>
         <p:nvSpPr>
-          <p:cNvPr id="25" name="Text 19"/>
+          <p:cNvPr id="25" name="Text 18"/>
           <p:cNvSpPr/>
           <p:nvPr/>
         </p:nvSpPr>
@@ -4951,250 +4695,7 @@
       </p:sp>
       <p:sp>
         <p:nvSpPr>
-          <p:cNvPr id="26" name="Text 20"/>
-          <p:cNvSpPr/>
-          <p:nvPr/>
-        </p:nvSpPr>
-        <p:spPr>
-          <a:xfrm>
-            <a:off x="640080" y="4526280"/>
-            <a:ext cx="1645920" cy="365760"/>
-          </a:xfrm>
-          <a:prstGeom prst="rect">
-            <a:avLst/>
-          </a:prstGeom>
-          <a:noFill/>
-          <a:ln/>
-        </p:spPr>
-        <p:txBody>
-          <a:bodyPr wrap="square" lIns="0" tIns="0" rIns="0" bIns="0" rtlCol="0" anchor="ctr"/>
-          <a:lstStyle/>
-          <a:p>
-            <a:pPr indent="0" marL="0">
-              <a:buNone/>
-            </a:pPr>
-            <a:r>
-              <a:rPr lang="en-US" sz="1900" b="1" dirty="0">
-                <a:solidFill>
-                  <a:srgbClr val="FFC93C"/>
-                </a:solidFill>
-                <a:latin typeface="Arial" pitchFamily="34" charset="0"/>
-                <a:ea typeface="Arial" pitchFamily="34" charset="-122"/>
-                <a:cs typeface="Arial" pitchFamily="34" charset="-120"/>
-              </a:rPr>
-              <a:t>62 400+</a:t>
-            </a:r>
-            <a:endParaRPr lang="en-US" sz="1900" dirty="0"/>
-          </a:p>
-        </p:txBody>
-      </p:sp>
-      <p:sp>
-        <p:nvSpPr>
-          <p:cNvPr id="27" name="Text 21"/>
-          <p:cNvSpPr/>
-          <p:nvPr/>
-        </p:nvSpPr>
-        <p:spPr>
-          <a:xfrm>
-            <a:off x="640080" y="4901184"/>
-            <a:ext cx="1645920" cy="292608"/>
-          </a:xfrm>
-          <a:prstGeom prst="rect">
-            <a:avLst/>
-          </a:prstGeom>
-          <a:noFill/>
-          <a:ln/>
-        </p:spPr>
-        <p:txBody>
-          <a:bodyPr wrap="square" lIns="0" tIns="0" rIns="0" bIns="0" rtlCol="0" anchor="ctr"/>
-          <a:lstStyle/>
-          <a:p>
-            <a:pPr indent="0" marL="0">
-              <a:lnSpc>
-                <a:spcPts val="1500"/>
-              </a:lnSpc>
-              <a:buNone/>
-            </a:pPr>
-            <a:r>
-              <a:rPr lang="en-US" sz="1200" dirty="0">
-                <a:solidFill>
-                  <a:srgbClr val="A2A2B5"/>
-                </a:solidFill>
-                <a:latin typeface="Calibri" pitchFamily="34" charset="0"/>
-                <a:ea typeface="Calibri" pitchFamily="34" charset="-122"/>
-                <a:cs typeface="Calibri" pitchFamily="34" charset="-120"/>
-              </a:rPr>
-              <a:t>obunachi</a:t>
-            </a:r>
-            <a:endParaRPr lang="en-US" sz="1200" dirty="0"/>
-          </a:p>
-        </p:txBody>
-      </p:sp>
-      <p:sp>
-        <p:nvSpPr>
-          <p:cNvPr id="28" name="Text 22"/>
-          <p:cNvSpPr/>
-          <p:nvPr/>
-        </p:nvSpPr>
-        <p:spPr>
-          <a:xfrm>
-            <a:off x="2423160" y="4526280"/>
-            <a:ext cx="1645920" cy="365760"/>
-          </a:xfrm>
-          <a:prstGeom prst="rect">
-            <a:avLst/>
-          </a:prstGeom>
-          <a:noFill/>
-          <a:ln/>
-        </p:spPr>
-        <p:txBody>
-          <a:bodyPr wrap="square" lIns="0" tIns="0" rIns="0" bIns="0" rtlCol="0" anchor="ctr"/>
-          <a:lstStyle/>
-          <a:p>
-            <a:pPr indent="0" marL="0">
-              <a:buNone/>
-            </a:pPr>
-            <a:r>
-              <a:rPr lang="en-US" sz="1900" b="1" dirty="0">
-                <a:solidFill>
-                  <a:srgbClr val="FFC93C"/>
-                </a:solidFill>
-                <a:latin typeface="Arial" pitchFamily="34" charset="0"/>
-                <a:ea typeface="Arial" pitchFamily="34" charset="-122"/>
-                <a:cs typeface="Arial" pitchFamily="34" charset="-120"/>
-              </a:rPr>
-              <a:t>48</a:t>
-            </a:r>
-            <a:endParaRPr lang="en-US" sz="1900" dirty="0"/>
-          </a:p>
-        </p:txBody>
-      </p:sp>
-      <p:sp>
-        <p:nvSpPr>
-          <p:cNvPr id="29" name="Text 23"/>
-          <p:cNvSpPr/>
-          <p:nvPr/>
-        </p:nvSpPr>
-        <p:spPr>
-          <a:xfrm>
-            <a:off x="2423160" y="4901184"/>
-            <a:ext cx="1645920" cy="292608"/>
-          </a:xfrm>
-          <a:prstGeom prst="rect">
-            <a:avLst/>
-          </a:prstGeom>
-          <a:noFill/>
-          <a:ln/>
-        </p:spPr>
-        <p:txBody>
-          <a:bodyPr wrap="square" lIns="0" tIns="0" rIns="0" bIns="0" rtlCol="0" anchor="ctr"/>
-          <a:lstStyle/>
-          <a:p>
-            <a:pPr indent="0" marL="0">
-              <a:lnSpc>
-                <a:spcPts val="1500"/>
-              </a:lnSpc>
-              <a:buNone/>
-            </a:pPr>
-            <a:r>
-              <a:rPr lang="en-US" sz="1200" dirty="0">
-                <a:solidFill>
-                  <a:srgbClr val="A2A2B5"/>
-                </a:solidFill>
-                <a:latin typeface="Calibri" pitchFamily="34" charset="0"/>
-                <a:ea typeface="Calibri" pitchFamily="34" charset="-122"/>
-                <a:cs typeface="Calibri" pitchFamily="34" charset="-120"/>
-              </a:rPr>
-              <a:t>son / yil</a:t>
-            </a:r>
-            <a:endParaRPr lang="en-US" sz="1200" dirty="0"/>
-          </a:p>
-        </p:txBody>
-      </p:sp>
-      <p:sp>
-        <p:nvSpPr>
-          <p:cNvPr id="30" name="Text 24"/>
-          <p:cNvSpPr/>
-          <p:nvPr/>
-        </p:nvSpPr>
-        <p:spPr>
-          <a:xfrm>
-            <a:off x="4206240" y="4526280"/>
-            <a:ext cx="1645920" cy="365760"/>
-          </a:xfrm>
-          <a:prstGeom prst="rect">
-            <a:avLst/>
-          </a:prstGeom>
-          <a:noFill/>
-          <a:ln/>
-        </p:spPr>
-        <p:txBody>
-          <a:bodyPr wrap="square" lIns="0" tIns="0" rIns="0" bIns="0" rtlCol="0" anchor="ctr"/>
-          <a:lstStyle/>
-          <a:p>
-            <a:pPr indent="0" marL="0">
-              <a:buNone/>
-            </a:pPr>
-            <a:r>
-              <a:rPr lang="en-US" sz="1900" b="1" dirty="0">
-                <a:solidFill>
-                  <a:srgbClr val="FFC93C"/>
-                </a:solidFill>
-                <a:latin typeface="Arial" pitchFamily="34" charset="0"/>
-                <a:ea typeface="Arial" pitchFamily="34" charset="-122"/>
-                <a:cs typeface="Arial" pitchFamily="34" charset="-120"/>
-              </a:rPr>
-              <a:t>3,6 mln+</a:t>
-            </a:r>
-            <a:endParaRPr lang="en-US" sz="1900" dirty="0"/>
-          </a:p>
-        </p:txBody>
-      </p:sp>
-      <p:sp>
-        <p:nvSpPr>
-          <p:cNvPr id="31" name="Text 25"/>
-          <p:cNvSpPr/>
-          <p:nvPr/>
-        </p:nvSpPr>
-        <p:spPr>
-          <a:xfrm>
-            <a:off x="4206240" y="4901184"/>
-            <a:ext cx="1645920" cy="292608"/>
-          </a:xfrm>
-          <a:prstGeom prst="rect">
-            <a:avLst/>
-          </a:prstGeom>
-          <a:noFill/>
-          <a:ln/>
-        </p:spPr>
-        <p:txBody>
-          <a:bodyPr wrap="square" lIns="0" tIns="0" rIns="0" bIns="0" rtlCol="0" anchor="ctr"/>
-          <a:lstStyle/>
-          <a:p>
-            <a:pPr indent="0" marL="0">
-              <a:lnSpc>
-                <a:spcPts val="1500"/>
-              </a:lnSpc>
-              <a:buNone/>
-            </a:pPr>
-            <a:r>
-              <a:rPr lang="en-US" sz="1200" dirty="0">
-                <a:solidFill>
-                  <a:srgbClr val="A2A2B5"/>
-                </a:solidFill>
-                <a:latin typeface="Calibri" pitchFamily="34" charset="0"/>
-                <a:ea typeface="Calibri" pitchFamily="34" charset="-122"/>
-                <a:cs typeface="Calibri" pitchFamily="34" charset="-120"/>
-              </a:rPr>
-              <a:t>ko‘rish</a:t>
-            </a:r>
-            <a:endParaRPr lang="en-US" sz="1200" dirty="0"/>
-          </a:p>
-        </p:txBody>
-      </p:sp>
-      <p:sp>
-        <p:nvSpPr>
-          <p:cNvPr id="32" name="Text 26"/>
+          <p:cNvPr id="26" name="Text 19"/>
           <p:cNvSpPr/>
           <p:nvPr/>
         </p:nvSpPr>

</xml_diff>

<commit_message>
Swap cover art to the logo and trim the contact slide
- Cover now carries the square show logo; the poster moves to the contact slide
- Contact slide keeps phone (+998 95 124 44 84) and YouTube only

Co-Authored-By: Claude Opus 5 <noreply@anthropic.com>
Claude-Session: https://claude.ai/code/session_01VVcYFC7m6jyhEcLisEEnrF
</commit_message>
<xml_diff>
--- a/prezentatsiya/Shunaqasi_ham_bop_turadi_Kommersiya_taklifi.pptx
+++ b/prezentatsiya/Shunaqasi_ham_bop_turadi_Kommersiya_taklifi.pptx
@@ -1322,8 +1322,8 @@
               <a:rPr lang="en-US" dirty="0"/>
               <a:t>2:05–2:15 | Kontakt. Qora fon.
 MERGAN PRODUCTION · SHUNAQASI HAM BO‘P TURADI
-Telefon / Telegram / Instagram / YouTube — yakuniy logotip animatsiyasi.
-ESLATMA: telefon raqami va akkaunt manzillarini yakuniy ma’lumot bilan almashtiring.</a:t>
+Telefon: +998 95 124 44 84 · YouTube: Mergan Production
+Yakuniy logotip animatsiyasi.</a:t>
             </a:r>
             <a:endParaRPr lang="en-US" dirty="0"/>
           </a:p>
@@ -2417,7 +2417,7 @@
       </p:grpSpPr>
       <p:pic>
         <p:nvPicPr>
-          <p:cNvPr id="2" name="Image 0" descr="assets/poster.jpg">    </p:cNvPr>
+          <p:cNvPr id="2" name="Image 0" descr="assets/logo.jpg">    </p:cNvPr>
           <p:cNvPicPr>
             <a:picLocks noChangeAspect="1"/>
           </p:cNvPicPr>
@@ -2430,8 +2430,8 @@
         </p:blipFill>
         <p:spPr>
           <a:xfrm>
-            <a:off x="7269480" y="0"/>
-            <a:ext cx="4922215" cy="6858000"/>
+            <a:off x="7360920" y="1234440"/>
+            <a:ext cx="4389120" cy="4389120"/>
           </a:xfrm>
           <a:prstGeom prst="rect">
             <a:avLst/>
@@ -3969,7 +3969,7 @@
       </p:sp>
       <p:pic>
         <p:nvPicPr>
-          <p:cNvPr id="3" name="Image 0" descr="assets/logo.jpg">    </p:cNvPr>
+          <p:cNvPr id="3" name="Image 0" descr="assets/poster.jpg">    </p:cNvPr>
           <p:cNvPicPr>
             <a:picLocks noChangeAspect="1"/>
           </p:cNvPicPr>
@@ -3983,7 +3983,7 @@
         <p:spPr>
           <a:xfrm>
             <a:off x="640080" y="1371600"/>
-            <a:ext cx="3154680" cy="3154680"/>
+            <a:ext cx="2377440" cy="3154680"/>
           </a:xfrm>
           <a:prstGeom prst="rect">
             <a:avLst/>
@@ -4080,11 +4080,11 @@
         <p:spPr>
           <a:xfrm>
             <a:off x="6446520" y="1371600"/>
-            <a:ext cx="5102352" cy="4114800"/>
+            <a:ext cx="5102352" cy="3154680"/>
           </a:xfrm>
           <a:prstGeom prst="roundRect">
             <a:avLst>
-              <a:gd name="adj" fmla="val 2222"/>
+              <a:gd name="adj" fmla="val 2899"/>
             </a:avLst>
           </a:prstGeom>
           <a:solidFill>
@@ -4106,8 +4106,8 @@
         </p:nvSpPr>
         <p:spPr>
           <a:xfrm>
-            <a:off x="6766560" y="1847088"/>
-            <a:ext cx="603504" cy="603504"/>
+            <a:off x="6812280" y="2103120"/>
+            <a:ext cx="658368" cy="658368"/>
           </a:xfrm>
           <a:prstGeom prst="ellipse">
             <a:avLst/>
@@ -4139,8 +4139,8 @@
         </p:blipFill>
         <p:spPr>
           <a:xfrm>
-            <a:off x="6935541" y="2016069"/>
-            <a:ext cx="265542" cy="265542"/>
+            <a:off x="6996623" y="2287463"/>
+            <a:ext cx="289682" cy="289682"/>
           </a:xfrm>
           <a:prstGeom prst="rect">
             <a:avLst/>
@@ -4155,8 +4155,8 @@
         </p:nvSpPr>
         <p:spPr>
           <a:xfrm>
-            <a:off x="7543800" y="1810512"/>
-            <a:ext cx="3657600" cy="256032"/>
+            <a:off x="7680960" y="2057400"/>
+            <a:ext cx="3566160" cy="256032"/>
           </a:xfrm>
           <a:prstGeom prst="rect">
             <a:avLst/>
@@ -4194,8 +4194,8 @@
         </p:nvSpPr>
         <p:spPr>
           <a:xfrm>
-            <a:off x="7543800" y="2103120"/>
-            <a:ext cx="3657600" cy="320040"/>
+            <a:off x="7680960" y="2368296"/>
+            <a:ext cx="3566160" cy="347472"/>
           </a:xfrm>
           <a:prstGeom prst="rect">
             <a:avLst/>
@@ -4209,22 +4209,22 @@
           <a:p>
             <a:pPr indent="0" marL="0">
               <a:lnSpc>
-                <a:spcPts val="1800"/>
+                <a:spcPts val="2000"/>
               </a:lnSpc>
               <a:buNone/>
             </a:pPr>
             <a:r>
-              <a:rPr lang="en-US" sz="1400" dirty="0">
-                <a:solidFill>
-                  <a:srgbClr val="A2A2B5"/>
+              <a:rPr lang="en-US" sz="1600" dirty="0">
+                <a:solidFill>
+                  <a:srgbClr val="FFFFFF"/>
                 </a:solidFill>
                 <a:latin typeface="Calibri" pitchFamily="34" charset="0"/>
                 <a:ea typeface="Calibri" pitchFamily="34" charset="-122"/>
                 <a:cs typeface="Calibri" pitchFamily="34" charset="-120"/>
               </a:rPr>
-              <a:t>+998 __ ___ __ __</a:t>
-            </a:r>
-            <a:endParaRPr lang="en-US" sz="1400" dirty="0"/>
+              <a:t>+998 95 124 44 84</a:t>
+            </a:r>
+            <a:endParaRPr lang="en-US" sz="1600" dirty="0"/>
           </a:p>
         </p:txBody>
       </p:sp>
@@ -4236,8 +4236,8 @@
         </p:nvSpPr>
         <p:spPr>
           <a:xfrm>
-            <a:off x="6766560" y="2560320"/>
-            <a:ext cx="4462272" cy="9144"/>
+            <a:off x="6812280" y="2926080"/>
+            <a:ext cx="4416552" cy="9144"/>
           </a:xfrm>
           <a:prstGeom prst="rect">
             <a:avLst/>
@@ -4261,8 +4261,8 @@
         </p:nvSpPr>
         <p:spPr>
           <a:xfrm>
-            <a:off x="6766560" y="2807208"/>
-            <a:ext cx="603504" cy="603504"/>
+            <a:off x="6812280" y="3383280"/>
+            <a:ext cx="658368" cy="658368"/>
           </a:xfrm>
           <a:prstGeom prst="ellipse">
             <a:avLst/>
@@ -4294,8 +4294,8 @@
         </p:blipFill>
         <p:spPr>
           <a:xfrm>
-            <a:off x="6935541" y="2976189"/>
-            <a:ext cx="265542" cy="265542"/>
+            <a:off x="6996623" y="3567623"/>
+            <a:ext cx="289682" cy="289682"/>
           </a:xfrm>
           <a:prstGeom prst="rect">
             <a:avLst/>
@@ -4310,8 +4310,8 @@
         </p:nvSpPr>
         <p:spPr>
           <a:xfrm>
-            <a:off x="7543800" y="2770632"/>
-            <a:ext cx="3657600" cy="256032"/>
+            <a:off x="7680960" y="3337560"/>
+            <a:ext cx="3566160" cy="256032"/>
           </a:xfrm>
           <a:prstGeom prst="rect">
             <a:avLst/>
@@ -4335,7 +4335,7 @@
                 <a:ea typeface="Arial" pitchFamily="34" charset="-122"/>
                 <a:cs typeface="Arial" pitchFamily="34" charset="-120"/>
               </a:rPr>
-              <a:t>Telegram</a:t>
+              <a:t>YouTube</a:t>
             </a:r>
             <a:endParaRPr lang="en-US" sz="1050" dirty="0"/>
           </a:p>
@@ -4349,8 +4349,8 @@
         </p:nvSpPr>
         <p:spPr>
           <a:xfrm>
-            <a:off x="7543800" y="3063240"/>
-            <a:ext cx="3657600" cy="320040"/>
+            <a:off x="7680960" y="3648456"/>
+            <a:ext cx="3566160" cy="347472"/>
           </a:xfrm>
           <a:prstGeom prst="rect">
             <a:avLst/>
@@ -4364,338 +4364,28 @@
           <a:p>
             <a:pPr indent="0" marL="0">
               <a:lnSpc>
-                <a:spcPts val="1800"/>
+                <a:spcPts val="2000"/>
               </a:lnSpc>
               <a:buNone/>
             </a:pPr>
             <a:r>
-              <a:rPr lang="en-US" sz="1400" dirty="0">
-                <a:solidFill>
-                  <a:srgbClr val="A2A2B5"/>
+              <a:rPr lang="en-US" sz="1600" dirty="0">
+                <a:solidFill>
+                  <a:srgbClr val="FFFFFF"/>
                 </a:solidFill>
                 <a:latin typeface="Calibri" pitchFamily="34" charset="0"/>
                 <a:ea typeface="Calibri" pitchFamily="34" charset="-122"/>
                 <a:cs typeface="Calibri" pitchFamily="34" charset="-120"/>
               </a:rPr>
-              <a:t>@ ____________</a:t>
-            </a:r>
-            <a:endParaRPr lang="en-US" sz="1400" dirty="0"/>
-          </a:p>
-        </p:txBody>
-      </p:sp>
-      <p:sp>
-        <p:nvSpPr>
-          <p:cNvPr id="16" name="Shape 11"/>
-          <p:cNvSpPr/>
-          <p:nvPr/>
-        </p:nvSpPr>
-        <p:spPr>
-          <a:xfrm>
-            <a:off x="6766560" y="3520440"/>
-            <a:ext cx="4462272" cy="9144"/>
-          </a:xfrm>
-          <a:prstGeom prst="rect">
-            <a:avLst/>
-          </a:prstGeom>
-          <a:solidFill>
-            <a:srgbClr val="2E2E3D"/>
-          </a:solidFill>
-          <a:ln w="6350">
-            <a:solidFill>
-              <a:srgbClr val="2E2E3D"/>
-            </a:solidFill>
-            <a:prstDash val="solid"/>
-          </a:ln>
-        </p:spPr>
-      </p:sp>
-      <p:sp>
-        <p:nvSpPr>
-          <p:cNvPr id="17" name="Shape 12"/>
-          <p:cNvSpPr/>
-          <p:nvPr/>
-        </p:nvSpPr>
-        <p:spPr>
-          <a:xfrm>
-            <a:off x="6766560" y="3767328"/>
-            <a:ext cx="603504" cy="603504"/>
-          </a:xfrm>
-          <a:prstGeom prst="ellipse">
-            <a:avLst/>
-          </a:prstGeom>
-          <a:solidFill>
-            <a:srgbClr val="0D0D14"/>
-          </a:solidFill>
-          <a:ln w="9525">
-            <a:solidFill>
-              <a:srgbClr val="2E2E3D"/>
-            </a:solidFill>
-            <a:prstDash val="solid"/>
-          </a:ln>
-        </p:spPr>
-      </p:sp>
-      <p:pic>
-        <p:nvPicPr>
-          <p:cNvPr id="18" name="Image 3" descr="preencoded.png">    </p:cNvPr>
-          <p:cNvPicPr>
-            <a:picLocks noChangeAspect="1"/>
-          </p:cNvPicPr>
-          <p:nvPr/>
-        </p:nvPicPr>
-        <p:blipFill>
-          <a:blip r:embed="rId4"/>
-          <a:stretch>
-            <a:fillRect/>
-          </a:stretch>
-        </p:blipFill>
-        <p:spPr>
-          <a:xfrm>
-            <a:off x="6935541" y="3936309"/>
-            <a:ext cx="265542" cy="265542"/>
-          </a:xfrm>
-          <a:prstGeom prst="rect">
-            <a:avLst/>
-          </a:prstGeom>
-        </p:spPr>
-      </p:pic>
-      <p:sp>
-        <p:nvSpPr>
-          <p:cNvPr id="19" name="Text 13"/>
-          <p:cNvSpPr/>
-          <p:nvPr/>
-        </p:nvSpPr>
-        <p:spPr>
-          <a:xfrm>
-            <a:off x="7543800" y="3730752"/>
-            <a:ext cx="3657600" cy="256032"/>
-          </a:xfrm>
-          <a:prstGeom prst="rect">
-            <a:avLst/>
-          </a:prstGeom>
-          <a:noFill/>
-          <a:ln/>
-        </p:spPr>
-        <p:txBody>
-          <a:bodyPr wrap="square" lIns="0" tIns="0" rIns="0" bIns="0" rtlCol="0" anchor="ctr"/>
-          <a:lstStyle/>
-          <a:p>
-            <a:pPr indent="0" marL="0">
-              <a:buNone/>
-            </a:pPr>
-            <a:r>
-              <a:rPr lang="en-US" sz="1050" b="1" spc="150" kern="0" dirty="0">
-                <a:solidFill>
-                  <a:srgbClr val="FFC93C"/>
-                </a:solidFill>
-                <a:latin typeface="Arial" pitchFamily="34" charset="0"/>
-                <a:ea typeface="Arial" pitchFamily="34" charset="-122"/>
-                <a:cs typeface="Arial" pitchFamily="34" charset="-120"/>
-              </a:rPr>
-              <a:t>Instagram</a:t>
-            </a:r>
-            <a:endParaRPr lang="en-US" sz="1050" dirty="0"/>
-          </a:p>
-        </p:txBody>
-      </p:sp>
-      <p:sp>
-        <p:nvSpPr>
-          <p:cNvPr id="20" name="Text 14"/>
-          <p:cNvSpPr/>
-          <p:nvPr/>
-        </p:nvSpPr>
-        <p:spPr>
-          <a:xfrm>
-            <a:off x="7543800" y="4023360"/>
-            <a:ext cx="3657600" cy="320040"/>
-          </a:xfrm>
-          <a:prstGeom prst="rect">
-            <a:avLst/>
-          </a:prstGeom>
-          <a:noFill/>
-          <a:ln/>
-        </p:spPr>
-        <p:txBody>
-          <a:bodyPr wrap="square" lIns="0" tIns="0" rIns="0" bIns="0" rtlCol="0" anchor="ctr"/>
-          <a:lstStyle/>
-          <a:p>
-            <a:pPr indent="0" marL="0">
-              <a:lnSpc>
-                <a:spcPts val="1800"/>
-              </a:lnSpc>
-              <a:buNone/>
-            </a:pPr>
-            <a:r>
-              <a:rPr lang="en-US" sz="1400" dirty="0">
-                <a:solidFill>
-                  <a:srgbClr val="A2A2B5"/>
-                </a:solidFill>
-                <a:latin typeface="Calibri" pitchFamily="34" charset="0"/>
-                <a:ea typeface="Calibri" pitchFamily="34" charset="-122"/>
-                <a:cs typeface="Calibri" pitchFamily="34" charset="-120"/>
-              </a:rPr>
-              <a:t>@ ____________</a:t>
-            </a:r>
-            <a:endParaRPr lang="en-US" sz="1400" dirty="0"/>
-          </a:p>
-        </p:txBody>
-      </p:sp>
-      <p:sp>
-        <p:nvSpPr>
-          <p:cNvPr id="21" name="Shape 15"/>
-          <p:cNvSpPr/>
-          <p:nvPr/>
-        </p:nvSpPr>
-        <p:spPr>
-          <a:xfrm>
-            <a:off x="6766560" y="4480560"/>
-            <a:ext cx="4462272" cy="9144"/>
-          </a:xfrm>
-          <a:prstGeom prst="rect">
-            <a:avLst/>
-          </a:prstGeom>
-          <a:solidFill>
-            <a:srgbClr val="2E2E3D"/>
-          </a:solidFill>
-          <a:ln w="6350">
-            <a:solidFill>
-              <a:srgbClr val="2E2E3D"/>
-            </a:solidFill>
-            <a:prstDash val="solid"/>
-          </a:ln>
-        </p:spPr>
-      </p:sp>
-      <p:sp>
-        <p:nvSpPr>
-          <p:cNvPr id="22" name="Shape 16"/>
-          <p:cNvSpPr/>
-          <p:nvPr/>
-        </p:nvSpPr>
-        <p:spPr>
-          <a:xfrm>
-            <a:off x="6766560" y="4727448"/>
-            <a:ext cx="603504" cy="603504"/>
-          </a:xfrm>
-          <a:prstGeom prst="ellipse">
-            <a:avLst/>
-          </a:prstGeom>
-          <a:solidFill>
-            <a:srgbClr val="0D0D14"/>
-          </a:solidFill>
-          <a:ln w="9525">
-            <a:solidFill>
-              <a:srgbClr val="2E2E3D"/>
-            </a:solidFill>
-            <a:prstDash val="solid"/>
-          </a:ln>
-        </p:spPr>
-      </p:sp>
-      <p:pic>
-        <p:nvPicPr>
-          <p:cNvPr id="23" name="Image 4" descr="preencoded.png">    </p:cNvPr>
-          <p:cNvPicPr>
-            <a:picLocks noChangeAspect="1"/>
-          </p:cNvPicPr>
-          <p:nvPr/>
-        </p:nvPicPr>
-        <p:blipFill>
-          <a:blip r:embed="rId5"/>
-          <a:stretch>
-            <a:fillRect/>
-          </a:stretch>
-        </p:blipFill>
-        <p:spPr>
-          <a:xfrm>
-            <a:off x="6935541" y="4896429"/>
-            <a:ext cx="265542" cy="265542"/>
-          </a:xfrm>
-          <a:prstGeom prst="rect">
-            <a:avLst/>
-          </a:prstGeom>
-        </p:spPr>
-      </p:pic>
-      <p:sp>
-        <p:nvSpPr>
-          <p:cNvPr id="24" name="Text 17"/>
-          <p:cNvSpPr/>
-          <p:nvPr/>
-        </p:nvSpPr>
-        <p:spPr>
-          <a:xfrm>
-            <a:off x="7543800" y="4690872"/>
-            <a:ext cx="3657600" cy="256032"/>
-          </a:xfrm>
-          <a:prstGeom prst="rect">
-            <a:avLst/>
-          </a:prstGeom>
-          <a:noFill/>
-          <a:ln/>
-        </p:spPr>
-        <p:txBody>
-          <a:bodyPr wrap="square" lIns="0" tIns="0" rIns="0" bIns="0" rtlCol="0" anchor="ctr"/>
-          <a:lstStyle/>
-          <a:p>
-            <a:pPr indent="0" marL="0">
-              <a:buNone/>
-            </a:pPr>
-            <a:r>
-              <a:rPr lang="en-US" sz="1050" b="1" spc="150" kern="0" dirty="0">
-                <a:solidFill>
-                  <a:srgbClr val="FFC93C"/>
-                </a:solidFill>
-                <a:latin typeface="Arial" pitchFamily="34" charset="0"/>
-                <a:ea typeface="Arial" pitchFamily="34" charset="-122"/>
-                <a:cs typeface="Arial" pitchFamily="34" charset="-120"/>
-              </a:rPr>
-              <a:t>YouTube</a:t>
-            </a:r>
-            <a:endParaRPr lang="en-US" sz="1050" dirty="0"/>
-          </a:p>
-        </p:txBody>
-      </p:sp>
-      <p:sp>
-        <p:nvSpPr>
-          <p:cNvPr id="25" name="Text 18"/>
-          <p:cNvSpPr/>
-          <p:nvPr/>
-        </p:nvSpPr>
-        <p:spPr>
-          <a:xfrm>
-            <a:off x="7543800" y="4983480"/>
-            <a:ext cx="3657600" cy="320040"/>
-          </a:xfrm>
-          <a:prstGeom prst="rect">
-            <a:avLst/>
-          </a:prstGeom>
-          <a:noFill/>
-          <a:ln/>
-        </p:spPr>
-        <p:txBody>
-          <a:bodyPr wrap="square" lIns="0" tIns="0" rIns="0" bIns="0" rtlCol="0" anchor="ctr"/>
-          <a:lstStyle/>
-          <a:p>
-            <a:pPr indent="0" marL="0">
-              <a:lnSpc>
-                <a:spcPts val="1800"/>
-              </a:lnSpc>
-              <a:buNone/>
-            </a:pPr>
-            <a:r>
-              <a:rPr lang="en-US" sz="1400" dirty="0">
-                <a:solidFill>
-                  <a:srgbClr val="FFFFFF"/>
-                </a:solidFill>
-                <a:latin typeface="Calibri" pitchFamily="34" charset="0"/>
-                <a:ea typeface="Calibri" pitchFamily="34" charset="-122"/>
-                <a:cs typeface="Calibri" pitchFamily="34" charset="-120"/>
-              </a:rPr>
               <a:t>Mergan Production</a:t>
             </a:r>
-            <a:endParaRPr lang="en-US" sz="1400" dirty="0"/>
-          </a:p>
-        </p:txBody>
-      </p:sp>
-      <p:sp>
-        <p:nvSpPr>
-          <p:cNvPr id="26" name="Text 19"/>
+            <a:endParaRPr lang="en-US" sz="1600" dirty="0"/>
+          </a:p>
+        </p:txBody>
+      </p:sp>
+      <p:sp>
+        <p:nvSpPr>
+          <p:cNvPr id="16" name="Text 11"/>
           <p:cNvSpPr/>
           <p:nvPr/>
         </p:nvSpPr>

</xml_diff>